<commit_message>
Stage 8 review fixes: G-006
</commit_message>
<xml_diff>
--- a/output/heldback_firm_G/OsterquillData/Marketing/Working_Copies/2024/Copy of Plate_Acceptance_092424 (2).pptx
+++ b/output/heldback_firm_G/OsterquillData/Marketing/Working_Copies/2024/Copy of Plate_Acceptance_092424 (2).pptx
@@ -509,7 +509,7 @@
           <a:lstStyle/>
           <a:p>
             <a:r>
-              <a:t>NK: Lucia asked for the failed-plate route to be first, not last. Move it before the walk-through if there is time.</a:t>
+              <a:t>KM: Brindlewythe plate acceptance wording retained for discussion. Lucia: map acceptance decisions to Osterquill control validity and the investigation plan before local use.</a:t>
             </a:r>
           </a:p>
         </p:txBody>
@@ -3687,7 +3687,7 @@
                 </a:solidFill>
                 <a:latin typeface="Times New Roman"/>
               </a:rPr>
-              <a:t>In vitro assay-control training | Working copy 09/24/2024</a:t>
+              <a:t>Copy of Brindlewythe assay-control training | Working copy 09/24/2024</a:t>
             </a:r>
           </a:p>
         </p:txBody>
@@ -3948,7 +3948,7 @@
               <a:rPr sz="2000">
                 <a:latin typeface="Times New Roman"/>
               </a:rPr>
-              <a:t>Every plate carries its own positive and negative controls</a:t>
+              <a:t>Each assay run includes the controls required by its approved investigation plan or SOP</a:t>
             </a:r>
           </a:p>
           <a:p>
@@ -3957,7 +3957,7 @@
               <a:rPr sz="2000">
                 <a:latin typeface="Times New Roman"/>
               </a:rPr>
-              <a:t>Control validity is judged against the criteria in the study plan, not on the day</a:t>
+              <a:t>Control validity is judged against criteria fixed before results are reviewed</a:t>
             </a:r>
           </a:p>
           <a:p>
@@ -3966,7 +3966,7 @@
               <a:rPr sz="1700">
                 <a:latin typeface="Times New Roman"/>
               </a:rPr>
-              <a:t>Criteria are fixed before the first plate is read</a:t>
+              <a:t>Plate acceptance applies to plate assays; culture and electrophysiology records have their own acceptance checks</a:t>
             </a:r>
           </a:p>
           <a:p>
@@ -3975,7 +3975,7 @@
               <a:rPr sz="2000">
                 <a:latin typeface="Times New Roman"/>
               </a:rPr>
-              <a:t>A plate with an invalid control is not used for a potency or safety call</a:t>
+              <a:t>Data from a run with invalid controls are not used for a safety conclusion</a:t>
             </a:r>
           </a:p>
         </p:txBody>
@@ -4212,16 +4212,7 @@
               <a:rPr sz="1500">
                 <a:latin typeface="Times New Roman"/>
               </a:rPr>
-              <a:t>Vehicle and reference clastogen per culture</a:t>
-            </a:r>
-          </a:p>
-          <a:p>
-            <a:pPr lvl="1"/>
-            <a:r>
-              <a:rPr sz="1500">
-                <a:latin typeface="Times New Roman"/>
-              </a:rPr>
-              <a:t>Scoring only on valid cultures</a:t>
+              <a:t>Concurrent vehicle and appropriate positive controls; assess cytotoxicity and scoring eligibility</a:t>
             </a:r>
           </a:p>
           <a:p>
@@ -4239,7 +4230,7 @@
               <a:rPr sz="1500">
                 <a:latin typeface="Times New Roman"/>
               </a:rPr>
-              <a:t>Reference inhibitor on every run</a:t>
+              <a:t>Reference response and assay-specific suitability checks; hERG patch-clamp records are not plate-reader maps</a:t>
             </a:r>
           </a:p>
         </p:txBody>
@@ -4618,8 +4609,8 @@
         </p:blipFill>
         <p:spPr>
           <a:xfrm>
-            <a:off x="5257647" y="1280160"/>
-            <a:ext cx="1676400" cy="5029200"/>
+            <a:off x="5260314" y="1280160"/>
+            <a:ext cx="1671066" cy="5029200"/>
           </a:xfrm>
           <a:prstGeom prst="rect">
             <a:avLst/>
@@ -4738,7 +4729,7 @@
               <a:rPr sz="2000">
                 <a:latin typeface="Times New Roman"/>
               </a:rPr>
-              <a:t>Plate acceptance decision and who made it</a:t>
+              <a:t>Plate acceptance / control-validity decision and responsible scientist</a:t>
             </a:r>
           </a:p>
           <a:p>
@@ -4747,7 +4738,7 @@
               <a:rPr sz="2000">
                 <a:latin typeface="Times New Roman"/>
               </a:rPr>
-              <a:t>Any repeat plate, with the reason</a:t>
+              <a:t>Failed run and any repeat, with the reason; retain all original observations</a:t>
             </a:r>
           </a:p>
           <a:p>
@@ -4756,7 +4747,16 @@
               <a:rPr sz="2000">
                 <a:latin typeface="Times New Roman"/>
               </a:rPr>
-              <a:t>Study amendment reference if the criteria changed during the work</a:t>
+              <a:t>Record departures as deviations; prospective plan changes require an authorised amendment, never retrospective relaxation of acceptance criteria</a:t>
+            </a:r>
+          </a:p>
+          <a:p>
+            <a:pPr/>
+            <a:r>
+              <a:rPr sz="2000">
+                <a:latin typeface="Times New Roman"/>
+              </a:rPr>
+              <a:t>Exploratory in vitro results carry their actual quality status; GLP conclusions require the applicable approved plan and QA review</a:t>
             </a:r>
           </a:p>
         </p:txBody>
@@ -4916,7 +4916,7 @@
               <a:rPr sz="2000">
                 <a:latin typeface="Times New Roman"/>
               </a:rPr>
-              <a:t>Kenji Morita, Scientist (mutagenicity)</a:t>
+              <a:t>Kenji Morita, genetic toxicology scientist</a:t>
             </a:r>
           </a:p>
           <a:p>

</xml_diff>